<commit_message>
prepare strict replay training handoff
</commit_message>
<xml_diff>
--- a/reports/defense_deck_20260329.pptx
+++ b/reports/defense_deck_20260329.pptx
@@ -3976,8 +3976,8 @@
                 </a:solidFill>
                 <a:latin typeface="Aptos"/>
               </a:rPr>
-              <a:t>Use Qwen PE + RAG + FT when peak score matters most.
-This is the best completed open-source combination in the ablation matrix.</a:t>
+              <a:t>Use Qwen PE + RAG + FT when discussing the historical formal matrix.
+Strict-clean FT rerun is still pending on a GPU environment.</a:t>
             </a:r>
           </a:p>
         </p:txBody>
@@ -4090,8 +4090,8 @@
                 </a:solidFill>
                 <a:latin typeface="Aptos"/>
               </a:rPr>
-              <a:t>Use Qwen PE + FT when engineering cost matters.
-It is only slightly below the full best line while being simpler to operate.</a:t>
+              <a:t>Use Qwen PE + FT as the historical formal default route.
+Promote it as strict-clean only after the FT family rerun lands.</a:t>
             </a:r>
           </a:p>
         </p:txBody>
@@ -4326,7 +4326,20 @@
               </a:defRPr>
             </a:pPr>
             <a:r>
-              <a:t>Evidence for 'no overfitting' is moderate, not maximal, because we do not keep a full step-wise eval curve</a:t>
+              <a:t>Evidence for 'no overfitting' is moderate, not maximal, because the historical run did not keep a full step-wise eval curve</a:t>
+            </a:r>
+          </a:p>
+          <a:p>
+            <a:pPr>
+              <a:defRPr sz="1400">
+                <a:solidFill>
+                  <a:srgbClr val="0F172A"/>
+                </a:solidFill>
+                <a:latin typeface="Aptos"/>
+              </a:defRPr>
+            </a:pPr>
+            <a:r>
+              <a:t>The strict replay config now fixes this with eval_steps/save_steps=50 and best-checkpoint selection</a:t>
             </a:r>
           </a:p>
           <a:p>

</xml_diff>

<commit_message>
sync final delivery with completed strict-clean results
</commit_message>
<xml_diff>
--- a/reports/defense_deck_20260329.pptx
+++ b/reports/defense_deck_20260329.pptx
@@ -3976,8 +3976,8 @@
                 </a:solidFill>
                 <a:latin typeface="Aptos"/>
               </a:rPr>
-              <a:t>Use Qwen PE + RAG + FT when discussing the historical formal matrix.
-Strict-clean FT rerun is still pending on a GPU environment.</a:t>
+              <a:t>Use Qwen PE + RAG + FT as the current strict-clean highest-score route.
+It is the strongest complete open-source path in the repo.</a:t>
             </a:r>
           </a:p>
         </p:txBody>
@@ -4090,8 +4090,8 @@
                 </a:solidFill>
                 <a:latin typeface="Aptos"/>
               </a:rPr>
-              <a:t>Use Qwen PE + FT as the historical formal default route.
-Promote it as strict-clean only after the FT family rerun lands.</a:t>
+              <a:t>Use Qwen PE + FT as the lower-complexity strict-clean route.
+Keep historical 0.4315 only as an archived comparison point.</a:t>
             </a:r>
           </a:p>
         </p:txBody>
@@ -9603,7 +9603,7 @@
                 </a:solidFill>
                 <a:latin typeface="Aptos"/>
               </a:rPr>
-              <a:t>0.4315</a:t>
+              <a:t>0.3865</a:t>
             </a:r>
           </a:p>
         </p:txBody>
@@ -9863,8 +9863,8 @@
                 </a:solidFill>
                 <a:latin typeface="Aptos"/>
               </a:rPr>
-              <a:t>Highest score: PE + RAG + FT = 0.4435
-Default cost-effective route: PE + FT = 0.4315</a:t>
+              <a:t>Highest strict-clean score: PE + RAG + FT = 0.5018
+Lower-complexity strict route: PE + FT = 0.3865</a:t>
             </a:r>
           </a:p>
         </p:txBody>

</xml_diff>

<commit_message>
fix delivery audit gaps and strict defaults
</commit_message>
<xml_diff>
--- a/reports/defense_deck_20260329.pptx
+++ b/reports/defense_deck_20260329.pptx
@@ -4313,7 +4313,7 @@
               </a:defRPr>
             </a:pPr>
             <a:r>
-              <a:t>The training curve is stable and the final eval_loss is 0.4779</a:t>
+              <a:t>The current strict-clean training curve is stable, with best eval_loss 0.4661 and last logged eval_loss 0.4664</a:t>
             </a:r>
           </a:p>
           <a:p>
@@ -4326,7 +4326,7 @@
               </a:defRPr>
             </a:pPr>
             <a:r>
-              <a:t>Evidence for 'no overfitting' is moderate, not maximal, because the historical run did not keep a full step-wise eval curve</a:t>
+              <a:t>This run keeps a step-wise eval curve and intermediate checkpoints, so the training evidence is materially stronger than the historical formal run</a:t>
             </a:r>
           </a:p>
           <a:p>
@@ -4339,7 +4339,7 @@
               </a:defRPr>
             </a:pPr>
             <a:r>
-              <a:t>The strict replay config now fixes this with eval_steps/save_steps=50 and best-checkpoint selection</a:t>
+              <a:t>The strict replay config fixed the old issue by using eval_steps/save_steps=50 and best-checkpoint selection</a:t>
             </a:r>
           </a:p>
           <a:p>

</xml_diff>